<commit_message>
Tone down language in slides to consultant reporting style
過剰に丁寧な言い回し・詩的な表現を削除し、報告書調に統一。
- 「うたかた様」「お話しできれば」等を削除
- クロージングを「以上 / ご質問・ご意見をお願いします」に変更
- 各セクションのタイトルとサブを簡潔に
- フッターメッセージも事実ベースに
</commit_message>
<xml_diff>
--- a/salon-slides.pptx
+++ b/salon-slides.pptx
@@ -3216,7 +3216,7 @@
                 </a:solidFill>
                 <a:latin typeface="Yu Mincho"/>
               </a:rPr>
-              <a:t>SNS運用</a:t>
+              <a:t>SNS運用ご提案</a:t>
             </a:r>
           </a:p>
         </p:txBody>
@@ -3255,7 +3255,7 @@
                 </a:solidFill>
                 <a:latin typeface="Yu Mincho"/>
               </a:rPr>
-              <a:t>ご提案・第2回</a:t>
+              <a:t>第2回</a:t>
             </a:r>
           </a:p>
         </p:txBody>
@@ -3337,7 +3337,7 @@
                 </a:solidFill>
                 <a:latin typeface="Yu Mincho"/>
               </a:rPr>
-              <a:t>前回のヒアリング振り返り ＆ 次の打ち手のご報告</a:t>
+              <a:t>前回ヒアリングの振り返りと提案</a:t>
             </a:r>
           </a:p>
         </p:txBody>
@@ -3376,7 +3376,7 @@
                 </a:solidFill>
                 <a:latin typeface="Consolas"/>
               </a:rPr>
-              <a:t>PRESENTED BY  山田     /     2026</a:t>
+              <a:t>山田     /     2026</a:t>
             </a:r>
           </a:p>
         </p:txBody>
@@ -3628,7 +3628,7 @@
                 </a:solidFill>
                 <a:latin typeface="Yu Gothic"/>
               </a:rPr>
-              <a:t>3つのエリアが固定され、その中で動画とテロップが流れます</a:t>
+              <a:t>上下の固定枠と中央の動画エリアの3層構造</a:t>
             </a:r>
           </a:p>
         </p:txBody>
@@ -4153,7 +4153,7 @@
                 </a:solidFill>
                 <a:latin typeface="Yu Gothic"/>
               </a:rPr>
-              <a:t>撮影素材をそのまま入れるだけ</a:t>
+              <a:t>撮影素材をそのまま入力</a:t>
             </a:r>
           </a:p>
         </p:txBody>
@@ -4387,7 +4387,7 @@
                 </a:solidFill>
                 <a:latin typeface="Yu Gothic"/>
               </a:rPr>
-              <a:t>0〜15秒は文言A、15〜30秒は文言Bのように</a:t>
+              <a:t>0〜15秒は文言A、15〜30秒は文言B</a:t>
             </a:r>
           </a:p>
         </p:txBody>
@@ -4461,7 +4461,7 @@
                 </a:solidFill>
                 <a:latin typeface="Yu Gothic"/>
               </a:rPr>
-              <a:t>テロップが動画に被らない構造 → 顔出しシーンも安心</a:t>
+              <a:t>テロップが動画に被らない構造</a:t>
             </a:r>
           </a:p>
         </p:txBody>
@@ -4713,7 +4713,7 @@
                 </a:solidFill>
                 <a:latin typeface="Yu Gothic"/>
               </a:rPr>
-              <a:t>本日その場で一緒に1本作ってみましょう</a:t>
+              <a:t>本日デモで実演</a:t>
             </a:r>
           </a:p>
         </p:txBody>
@@ -4950,7 +4950,7 @@
                 </a:solidFill>
                 <a:latin typeface="Yu Gothic"/>
               </a:rPr>
-              <a:t>30秒前後がベスト。</a:t>
+              <a:t>30秒前後が目安。</a:t>
             </a:r>
           </a:p>
         </p:txBody>
@@ -5171,23 +5171,7 @@
                 </a:solidFill>
                 <a:latin typeface="Yu Gothic"/>
               </a:rPr>
-              <a:t>クレイの3種から</a:t>
-            </a:r>
-          </a:p>
-          <a:p>
-            <a:pPr algn="l">
-              <a:lnSpc>
-                <a:spcPct val="160000"/>
-              </a:lnSpc>
-            </a:pPr>
-            <a:r>
-              <a:rPr sz="1000" b="0" i="0">
-                <a:solidFill>
-                  <a:srgbClr val="7A7A7A"/>
-                </a:solidFill>
-                <a:latin typeface="Yu Gothic"/>
-              </a:rPr>
-              <a:t>雰囲気を選ぶ。</a:t>
+              <a:t>クレイの3種から選択。</a:t>
             </a:r>
           </a:p>
         </p:txBody>
@@ -5629,7 +5613,7 @@
                 </a:solidFill>
                 <a:latin typeface="Yu Gothic"/>
               </a:rPr>
-              <a:t>ボタン1つでMP4が完成。</a:t>
+              <a:t>ボタン1つでMP4が出力。</a:t>
             </a:r>
           </a:p>
           <a:p>
@@ -5700,7 +5684,7 @@
                 </a:solidFill>
                 <a:latin typeface="Yu Gothic"/>
               </a:rPr>
-              <a:t>慣れれば 1本あたり10分 で完成します</a:t>
+              <a:t>1本あたり目安 10分</a:t>
             </a:r>
           </a:p>
         </p:txBody>
@@ -6026,7 +6010,7 @@
                 </a:solidFill>
                 <a:latin typeface="Yu Gothic"/>
               </a:rPr>
-              <a:t>無理せず、まずは小さく試すところから</a:t>
+              <a:t>段階的に導入</a:t>
             </a:r>
           </a:p>
         </p:txBody>
@@ -6188,7 +6172,7 @@
                 </a:solidFill>
                 <a:latin typeface="Yu Gothic"/>
               </a:rPr>
-              <a:t>・ChatGPTにプロジェクト用プロンプトを貼る</a:t>
+              <a:t>・ChatGPTにプロジェクト用プロンプトを設定</a:t>
             </a:r>
           </a:p>
           <a:p>
@@ -6204,7 +6188,7 @@
                 </a:solidFill>
                 <a:latin typeface="Yu Gothic"/>
               </a:rPr>
-              <a:t>・「リール5本」を1回試す</a:t>
+              <a:t>・「リール5本」を1回実行</a:t>
             </a:r>
           </a:p>
           <a:p>
@@ -6220,7 +6204,7 @@
                 </a:solidFill>
                 <a:latin typeface="Yu Gothic"/>
               </a:rPr>
-              <a:t>・気になった案を1つ選ぶ</a:t>
+              <a:t>・出力から1案を選定</a:t>
             </a:r>
           </a:p>
         </p:txBody>
@@ -6382,7 +6366,7 @@
                 </a:solidFill>
                 <a:latin typeface="Yu Gothic"/>
               </a:rPr>
-              <a:t>・普段の撮影素材を1本用意</a:t>
+              <a:t>・撮影素材を1本用意</a:t>
             </a:r>
           </a:p>
           <a:p>
@@ -6398,7 +6382,7 @@
                 </a:solidFill>
                 <a:latin typeface="Yu Gothic"/>
               </a:rPr>
-              <a:t>・エディタで枠付き動画にする</a:t>
+              <a:t>・エディタで枠付き動画化</a:t>
             </a:r>
           </a:p>
           <a:p>
@@ -6537,7 +6521,7 @@
                 </a:solidFill>
                 <a:latin typeface="Yu Mincho"/>
               </a:rPr>
-              <a:t>慣れる・調整</a:t>
+              <a:t>運用に乗せる</a:t>
             </a:r>
           </a:p>
         </p:txBody>
@@ -6576,7 +6560,7 @@
                 </a:solidFill>
                 <a:latin typeface="Yu Gothic"/>
               </a:rPr>
-              <a:t>・もう1〜2本作ってみる</a:t>
+              <a:t>・もう1〜2本作成</a:t>
             </a:r>
           </a:p>
           <a:p>
@@ -6608,7 +6592,7 @@
                 </a:solidFill>
                 <a:latin typeface="Yu Gothic"/>
               </a:rPr>
-              <a:t>・次回ご相談</a:t>
+              <a:t>・次回ヒアリングで共有</a:t>
             </a:r>
           </a:p>
         </p:txBody>
@@ -6682,7 +6666,7 @@
                 </a:solidFill>
                 <a:latin typeface="Yu Gothic"/>
               </a:rPr>
-              <a:t>次回お会いした時に「やってみてどうだったか」を一緒に振り返ります</a:t>
+              <a:t>次回ヒアリングで運用状況を確認</a:t>
             </a:r>
           </a:p>
         </p:txBody>
@@ -6756,7 +6740,7 @@
         </p:nvSpPr>
         <p:spPr>
           <a:xfrm>
-            <a:off x="0" y="2286000"/>
+            <a:off x="0" y="2743200"/>
             <a:ext cx="9144000" cy="914400"/>
           </a:xfrm>
           <a:prstGeom prst="rect">
@@ -6782,7 +6766,7 @@
                 </a:solidFill>
                 <a:latin typeface="Yu Mincho"/>
               </a:rPr>
-              <a:t>うたかたが続くように</a:t>
+              <a:t>以上</a:t>
             </a:r>
           </a:p>
         </p:txBody>
@@ -6795,7 +6779,7 @@
         </p:nvSpPr>
         <p:spPr>
           <a:xfrm>
-            <a:off x="4297680" y="3657600"/>
+            <a:off x="4297680" y="3840480"/>
             <a:ext cx="548640" cy="9525"/>
           </a:xfrm>
           <a:prstGeom prst="rect">
@@ -6838,8 +6822,8 @@
         </p:nvSpPr>
         <p:spPr>
           <a:xfrm>
-            <a:off x="0" y="4114800"/>
-            <a:ext cx="9144000" cy="1828800"/>
+            <a:off x="0" y="4297680"/>
+            <a:ext cx="9144000" cy="548640"/>
           </a:xfrm>
           <a:prstGeom prst="rect">
             <a:avLst/>
@@ -6854,7 +6838,7 @@
           <a:p>
             <a:pPr algn="ctr">
               <a:lnSpc>
-                <a:spcPct val="200000"/>
+                <a:spcPct val="140000"/>
               </a:lnSpc>
             </a:pPr>
             <a:r>
@@ -6864,39 +6848,7 @@
                 </a:solidFill>
                 <a:latin typeface="Yu Gothic"/>
               </a:rPr>
-              <a:t>「整える時間」を、整えながら届けられるように。</a:t>
-            </a:r>
-          </a:p>
-          <a:p>
-            <a:pPr algn="ctr">
-              <a:lnSpc>
-                <a:spcPct val="200000"/>
-              </a:lnSpc>
-            </a:pPr>
-            <a:r>
-              <a:rPr sz="1200" b="0" i="0">
-                <a:solidFill>
-                  <a:srgbClr val="CFCBC0"/>
-                </a:solidFill>
-                <a:latin typeface="Yu Gothic"/>
-              </a:rPr>
-              <a:t>無理せず、長く続けられる仕組みを</a:t>
-            </a:r>
-          </a:p>
-          <a:p>
-            <a:pPr algn="ctr">
-              <a:lnSpc>
-                <a:spcPct val="200000"/>
-              </a:lnSpc>
-            </a:pPr>
-            <a:r>
-              <a:rPr sz="1200" b="0" i="0">
-                <a:solidFill>
-                  <a:srgbClr val="CFCBC0"/>
-                </a:solidFill>
-                <a:latin typeface="Yu Gothic"/>
-              </a:rPr>
-              <a:t>これからも一緒に組み立てさせてください。</a:t>
+              <a:t>ご質問・ご意見をお願いします</a:t>
             </a:r>
           </a:p>
         </p:txBody>
@@ -7109,7 +7061,7 @@
                 </a:solidFill>
                 <a:latin typeface="Yu Mincho"/>
               </a:rPr>
-              <a:t>本日お話しすること</a:t>
+              <a:t>アジェンダ</a:t>
             </a:r>
           </a:p>
         </p:txBody>
@@ -7148,7 +7100,7 @@
                 </a:solidFill>
                 <a:latin typeface="Yu Gothic"/>
               </a:rPr>
-              <a:t>前回お聞きしたお悩みをもとに、整理したものをご報告します</a:t>
+              <a:t>前回ヒアリングの振り返りと、今回の提案2点</a:t>
             </a:r>
           </a:p>
         </p:txBody>
@@ -7226,7 +7178,7 @@
                 </a:solidFill>
                 <a:latin typeface="Yu Mincho"/>
               </a:rPr>
-              <a:t>前回のヒアリング振り返り</a:t>
+              <a:t>前回ヒアリングの振り返り</a:t>
             </a:r>
           </a:p>
         </p:txBody>
@@ -7265,7 +7217,7 @@
                 </a:solidFill>
                 <a:latin typeface="Yu Gothic"/>
               </a:rPr>
-              <a:t>どんなお悩みが出てきたか、その整理</a:t>
+              <a:t>前回出た課題の整理</a:t>
             </a:r>
           </a:p>
         </p:txBody>
@@ -7378,7 +7330,7 @@
                 </a:solidFill>
                 <a:latin typeface="Yu Mincho"/>
               </a:rPr>
-              <a:t>【提案①】プロンプト一覧のご紹介</a:t>
+              <a:t>提案① プロンプト一覧</a:t>
             </a:r>
           </a:p>
         </p:txBody>
@@ -7417,7 +7369,7 @@
                 </a:solidFill>
                 <a:latin typeface="Yu Gothic"/>
               </a:rPr>
-              <a:t>ChatGPTで投稿の言葉づくりを楽にする道具</a:t>
+              <a:t>投稿の言葉づくり用ツール</a:t>
             </a:r>
           </a:p>
         </p:txBody>
@@ -7530,7 +7482,7 @@
                 </a:solidFill>
                 <a:latin typeface="Yu Mincho"/>
               </a:rPr>
-              <a:t>【提案②】動画エディタの使い方レクチャー</a:t>
+              <a:t>提案② 動画エディタ</a:t>
             </a:r>
           </a:p>
         </p:txBody>
@@ -7569,7 +7521,7 @@
                 </a:solidFill>
                 <a:latin typeface="Yu Gothic"/>
               </a:rPr>
-              <a:t>テロップ位置を悩まずに済む、ブラウザツール</a:t>
+              <a:t>テロップ位置調整不要の編集ツール</a:t>
             </a:r>
           </a:p>
         </p:txBody>
@@ -7721,7 +7673,7 @@
                 </a:solidFill>
                 <a:latin typeface="Yu Gothic"/>
               </a:rPr>
-              <a:t>3週間で無理なく取り入れる順番</a:t>
+              <a:t>3週間の導入計画</a:t>
             </a:r>
           </a:p>
         </p:txBody>
@@ -7830,7 +7782,7 @@
                 </a:solidFill>
                 <a:latin typeface="Yu Gothic"/>
               </a:rPr>
-              <a:t>30分のお時間で、ゆっくりお話しできればと思います</a:t>
+              <a:t>所要 約30分</a:t>
             </a:r>
           </a:p>
         </p:txBody>
@@ -8043,7 +7995,7 @@
                 </a:solidFill>
                 <a:latin typeface="Yu Mincho"/>
               </a:rPr>
-              <a:t>前回のヒアリングで見えてきたこと</a:t>
+              <a:t>前回ヒアリングで出た課題</a:t>
             </a:r>
           </a:p>
         </p:txBody>
@@ -8082,7 +8034,7 @@
                 </a:solidFill>
                 <a:latin typeface="Yu Gothic"/>
               </a:rPr>
-              <a:t>うたかた様から伺ったお悩み・違和感を、4つに整理しました</a:t>
+              <a:t>ヒアリング内容を4点に整理</a:t>
             </a:r>
           </a:p>
         </p:txBody>
@@ -8884,7 +8836,7 @@
                 </a:solidFill>
                 <a:latin typeface="Yu Gothic"/>
               </a:rPr>
-              <a:t>※ 前回のメモから抜粋。漏れがあれば後ほど追記します</a:t>
+              <a:t>※ ヒアリングメモから抜粋</a:t>
             </a:r>
           </a:p>
         </p:txBody>
@@ -9097,7 +9049,7 @@
                 </a:solidFill>
                 <a:latin typeface="Yu Mincho"/>
               </a:rPr>
-              <a:t>大事にしていらっしゃること</a:t>
+              <a:t>ブランドの軸</a:t>
             </a:r>
           </a:p>
         </p:txBody>
@@ -9136,7 +9088,7 @@
                 </a:solidFill>
                 <a:latin typeface="Yu Gothic"/>
               </a:rPr>
-              <a:t>これを軸に、すべての提案を組み立てています</a:t>
+              <a:t>提案の判断基準</a:t>
             </a:r>
           </a:p>
         </p:txBody>
@@ -9792,7 +9744,7 @@
                 </a:solidFill>
                 <a:latin typeface="Yu Gothic"/>
               </a:rPr>
-              <a:t>この3つの軸から外れたものはご提案しません</a:t>
+              <a:t>提案はこの軸に沿って組み立て</a:t>
             </a:r>
           </a:p>
         </p:txBody>
@@ -10005,7 +9957,7 @@
                 </a:solidFill>
                 <a:latin typeface="Yu Mincho"/>
               </a:rPr>
-              <a:t>3つのアプローチで楽にしていきます</a:t>
+              <a:t>3つのアプローチ</a:t>
             </a:r>
           </a:p>
         </p:txBody>
@@ -10044,7 +9996,7 @@
                 </a:solidFill>
                 <a:latin typeface="Yu Gothic"/>
               </a:rPr>
-              <a:t>「すべてAI任せ」ではなく、人の判断は残しつつ手間だけ減らす</a:t>
+              <a:t>AI任せにせず、人の判断を残す設計</a:t>
             </a:r>
           </a:p>
         </p:txBody>
@@ -10626,7 +10578,7 @@
                 </a:solidFill>
                 <a:latin typeface="Yu Mincho"/>
               </a:rPr>
-              <a:t>本日は ① と ② をご紹介します。</a:t>
+              <a:t>本日は ① と ② を扱う。</a:t>
             </a:r>
           </a:p>
           <a:p>
@@ -10642,7 +10594,7 @@
                 </a:solidFill>
                 <a:latin typeface="Yu Mincho"/>
               </a:rPr>
-              <a:t>③（撮影設計）は別途お渡ししたガイドをご覧ください。</a:t>
+              <a:t>③（撮影設計）は別資料を参照。</a:t>
             </a:r>
           </a:p>
         </p:txBody>
@@ -11050,7 +11002,7 @@
                 </a:solidFill>
                 <a:latin typeface="Yu Gothic"/>
               </a:rPr>
-              <a:t>「何を投稿しよう？」を5秒で解決する道具箱</a:t>
+              <a:t>ChatGPTで投稿の言葉づくりを高速化</a:t>
             </a:r>
           </a:p>
         </p:txBody>
@@ -11089,7 +11041,7 @@
                 </a:solidFill>
                 <a:latin typeface="Yu Mincho"/>
               </a:rPr>
-              <a:t>ChatGPTに「リール5本」と打つだけで、</a:t>
+              <a:t>ChatGPTに「リール5本」のような短いトリガー語を打つと、</a:t>
             </a:r>
           </a:p>
           <a:p>
@@ -11105,7 +11057,7 @@
                 </a:solidFill>
                 <a:latin typeface="Yu Mincho"/>
               </a:rPr>
-              <a:t>うたかたらしい台本が5本まとめて生成される、というイメージです。</a:t>
+              <a:t>ブランドに沿った投稿案がまとめて出力される仕組み。</a:t>
             </a:r>
           </a:p>
           <a:p>
@@ -11137,7 +11089,7 @@
                 </a:solidFill>
                 <a:latin typeface="Yu Mincho"/>
               </a:rPr>
-              <a:t>毎回ゼロから考える必要がなくなります。</a:t>
+              <a:t>投稿のたびにゼロから考える時間を削減。</a:t>
             </a:r>
           </a:p>
         </p:txBody>
@@ -11463,7 +11415,7 @@
                 </a:solidFill>
                 <a:latin typeface="Yu Gothic"/>
               </a:rPr>
-              <a:t>用途別に短い言葉を1つ打つだけで、必要な発信素材が出てきます</a:t>
+              <a:t>用途別のトリガー語を15種類用意</a:t>
             </a:r>
           </a:p>
         </p:txBody>
@@ -13382,7 +13334,7 @@
                 </a:solidFill>
                 <a:latin typeface="Yu Gothic"/>
               </a:rPr>
-              <a:t>たとえば「今月どうしよう」→「月次テーマ」と打つだけ</a:t>
+              <a:t>例: 月の方針が定まらない時は「月次テーマ」</a:t>
             </a:r>
           </a:p>
         </p:txBody>
@@ -13634,7 +13586,7 @@
                 </a:solidFill>
                 <a:latin typeface="Yu Gothic"/>
               </a:rPr>
-              <a:t>難しい操作は不要。事前準備は1回だけ。</a:t>
+              <a:t>事前準備は1回のみ</a:t>
             </a:r>
           </a:p>
         </p:txBody>
@@ -14478,7 +14430,7 @@
                 </a:solidFill>
                 <a:latin typeface="Yu Gothic"/>
               </a:rPr>
-              <a:t>投稿1本あたり 3〜5分 で言葉が決まります</a:t>
+              <a:t>1投稿あたり 3〜5分 で完成</a:t>
             </a:r>
           </a:p>
         </p:txBody>
@@ -14552,7 +14504,7 @@
                 </a:solidFill>
                 <a:latin typeface="Yu Gothic"/>
               </a:rPr>
-              <a:t>本日その場で1回試してみましょう</a:t>
+              <a:t>本日デモを実施</a:t>
             </a:r>
           </a:p>
         </p:txBody>
@@ -14886,7 +14838,7 @@
                 </a:solidFill>
                 <a:latin typeface="Yu Gothic"/>
               </a:rPr>
-              <a:t>テロップ位置を悩まずに済む、ブラウザで動く編集ツール</a:t>
+              <a:t>テロップ位置を悩まないブラウザ完結ツール</a:t>
             </a:r>
           </a:p>
         </p:txBody>
@@ -14941,7 +14893,7 @@
                 </a:solidFill>
                 <a:latin typeface="Yu Mincho"/>
               </a:rPr>
-              <a:t>動画の上下に固定された枠に文字を入れる仕組みです。</a:t>
+              <a:t>動画の上下に固定の枠を設けて文字を入れる仕組み。</a:t>
             </a:r>
           </a:p>
           <a:p>
@@ -14973,7 +14925,7 @@
                 </a:solidFill>
                 <a:latin typeface="Yu Mincho"/>
               </a:rPr>
-              <a:t>→ テロップが顔に被る心配がない</a:t>
+              <a:t>・テロップが顔に被らない</a:t>
             </a:r>
           </a:p>
           <a:p>
@@ -14989,7 +14941,7 @@
                 </a:solidFill>
                 <a:latin typeface="Yu Mincho"/>
               </a:rPr>
-              <a:t>→ 位置調整がいらない</a:t>
+              <a:t>・位置調整が不要</a:t>
             </a:r>
           </a:p>
           <a:p>
@@ -15005,7 +14957,7 @@
                 </a:solidFill>
                 <a:latin typeface="Yu Mincho"/>
               </a:rPr>
-              <a:t>→ うたかたらしい統一感を保ったまま量産できる</a:t>
+              <a:t>・ブランドの統一感を保ったまま量産可能</a:t>
             </a:r>
           </a:p>
         </p:txBody>

</xml_diff>

<commit_message>
Sync toned-down slides to main
</commit_message>
<xml_diff>
--- a/salon-slides.pptx
+++ b/salon-slides.pptx
@@ -3216,7 +3216,7 @@
                 </a:solidFill>
                 <a:latin typeface="Yu Mincho"/>
               </a:rPr>
-              <a:t>SNS運用</a:t>
+              <a:t>SNS運用ご提案</a:t>
             </a:r>
           </a:p>
         </p:txBody>
@@ -3255,7 +3255,7 @@
                 </a:solidFill>
                 <a:latin typeface="Yu Mincho"/>
               </a:rPr>
-              <a:t>ご提案・第2回</a:t>
+              <a:t>第2回</a:t>
             </a:r>
           </a:p>
         </p:txBody>
@@ -3337,7 +3337,7 @@
                 </a:solidFill>
                 <a:latin typeface="Yu Mincho"/>
               </a:rPr>
-              <a:t>前回のヒアリング振り返り ＆ 次の打ち手のご報告</a:t>
+              <a:t>前回ヒアリングの振り返りと提案</a:t>
             </a:r>
           </a:p>
         </p:txBody>
@@ -3376,7 +3376,7 @@
                 </a:solidFill>
                 <a:latin typeface="Consolas"/>
               </a:rPr>
-              <a:t>PRESENTED BY  山田     /     2026</a:t>
+              <a:t>山田     /     2026</a:t>
             </a:r>
           </a:p>
         </p:txBody>
@@ -3628,7 +3628,7 @@
                 </a:solidFill>
                 <a:latin typeface="Yu Gothic"/>
               </a:rPr>
-              <a:t>3つのエリアが固定され、その中で動画とテロップが流れます</a:t>
+              <a:t>上下の固定枠と中央の動画エリアの3層構造</a:t>
             </a:r>
           </a:p>
         </p:txBody>
@@ -4153,7 +4153,7 @@
                 </a:solidFill>
                 <a:latin typeface="Yu Gothic"/>
               </a:rPr>
-              <a:t>撮影素材をそのまま入れるだけ</a:t>
+              <a:t>撮影素材をそのまま入力</a:t>
             </a:r>
           </a:p>
         </p:txBody>
@@ -4387,7 +4387,7 @@
                 </a:solidFill>
                 <a:latin typeface="Yu Gothic"/>
               </a:rPr>
-              <a:t>0〜15秒は文言A、15〜30秒は文言Bのように</a:t>
+              <a:t>0〜15秒は文言A、15〜30秒は文言B</a:t>
             </a:r>
           </a:p>
         </p:txBody>
@@ -4461,7 +4461,7 @@
                 </a:solidFill>
                 <a:latin typeface="Yu Gothic"/>
               </a:rPr>
-              <a:t>テロップが動画に被らない構造 → 顔出しシーンも安心</a:t>
+              <a:t>テロップが動画に被らない構造</a:t>
             </a:r>
           </a:p>
         </p:txBody>
@@ -4713,7 +4713,7 @@
                 </a:solidFill>
                 <a:latin typeface="Yu Gothic"/>
               </a:rPr>
-              <a:t>本日その場で一緒に1本作ってみましょう</a:t>
+              <a:t>本日デモで実演</a:t>
             </a:r>
           </a:p>
         </p:txBody>
@@ -4950,7 +4950,7 @@
                 </a:solidFill>
                 <a:latin typeface="Yu Gothic"/>
               </a:rPr>
-              <a:t>30秒前後がベスト。</a:t>
+              <a:t>30秒前後が目安。</a:t>
             </a:r>
           </a:p>
         </p:txBody>
@@ -5171,23 +5171,7 @@
                 </a:solidFill>
                 <a:latin typeface="Yu Gothic"/>
               </a:rPr>
-              <a:t>クレイの3種から</a:t>
-            </a:r>
-          </a:p>
-          <a:p>
-            <a:pPr algn="l">
-              <a:lnSpc>
-                <a:spcPct val="160000"/>
-              </a:lnSpc>
-            </a:pPr>
-            <a:r>
-              <a:rPr sz="1000" b="0" i="0">
-                <a:solidFill>
-                  <a:srgbClr val="7A7A7A"/>
-                </a:solidFill>
-                <a:latin typeface="Yu Gothic"/>
-              </a:rPr>
-              <a:t>雰囲気を選ぶ。</a:t>
+              <a:t>クレイの3種から選択。</a:t>
             </a:r>
           </a:p>
         </p:txBody>
@@ -5629,7 +5613,7 @@
                 </a:solidFill>
                 <a:latin typeface="Yu Gothic"/>
               </a:rPr>
-              <a:t>ボタン1つでMP4が完成。</a:t>
+              <a:t>ボタン1つでMP4が出力。</a:t>
             </a:r>
           </a:p>
           <a:p>
@@ -5700,7 +5684,7 @@
                 </a:solidFill>
                 <a:latin typeface="Yu Gothic"/>
               </a:rPr>
-              <a:t>慣れれば 1本あたり10分 で完成します</a:t>
+              <a:t>1本あたり目安 10分</a:t>
             </a:r>
           </a:p>
         </p:txBody>
@@ -6026,7 +6010,7 @@
                 </a:solidFill>
                 <a:latin typeface="Yu Gothic"/>
               </a:rPr>
-              <a:t>無理せず、まずは小さく試すところから</a:t>
+              <a:t>段階的に導入</a:t>
             </a:r>
           </a:p>
         </p:txBody>
@@ -6188,7 +6172,7 @@
                 </a:solidFill>
                 <a:latin typeface="Yu Gothic"/>
               </a:rPr>
-              <a:t>・ChatGPTにプロジェクト用プロンプトを貼る</a:t>
+              <a:t>・ChatGPTにプロジェクト用プロンプトを設定</a:t>
             </a:r>
           </a:p>
           <a:p>
@@ -6204,7 +6188,7 @@
                 </a:solidFill>
                 <a:latin typeface="Yu Gothic"/>
               </a:rPr>
-              <a:t>・「リール5本」を1回試す</a:t>
+              <a:t>・「リール5本」を1回実行</a:t>
             </a:r>
           </a:p>
           <a:p>
@@ -6220,7 +6204,7 @@
                 </a:solidFill>
                 <a:latin typeface="Yu Gothic"/>
               </a:rPr>
-              <a:t>・気になった案を1つ選ぶ</a:t>
+              <a:t>・出力から1案を選定</a:t>
             </a:r>
           </a:p>
         </p:txBody>
@@ -6382,7 +6366,7 @@
                 </a:solidFill>
                 <a:latin typeface="Yu Gothic"/>
               </a:rPr>
-              <a:t>・普段の撮影素材を1本用意</a:t>
+              <a:t>・撮影素材を1本用意</a:t>
             </a:r>
           </a:p>
           <a:p>
@@ -6398,7 +6382,7 @@
                 </a:solidFill>
                 <a:latin typeface="Yu Gothic"/>
               </a:rPr>
-              <a:t>・エディタで枠付き動画にする</a:t>
+              <a:t>・エディタで枠付き動画化</a:t>
             </a:r>
           </a:p>
           <a:p>
@@ -6537,7 +6521,7 @@
                 </a:solidFill>
                 <a:latin typeface="Yu Mincho"/>
               </a:rPr>
-              <a:t>慣れる・調整</a:t>
+              <a:t>運用に乗せる</a:t>
             </a:r>
           </a:p>
         </p:txBody>
@@ -6576,7 +6560,7 @@
                 </a:solidFill>
                 <a:latin typeface="Yu Gothic"/>
               </a:rPr>
-              <a:t>・もう1〜2本作ってみる</a:t>
+              <a:t>・もう1〜2本作成</a:t>
             </a:r>
           </a:p>
           <a:p>
@@ -6608,7 +6592,7 @@
                 </a:solidFill>
                 <a:latin typeface="Yu Gothic"/>
               </a:rPr>
-              <a:t>・次回ご相談</a:t>
+              <a:t>・次回ヒアリングで共有</a:t>
             </a:r>
           </a:p>
         </p:txBody>
@@ -6682,7 +6666,7 @@
                 </a:solidFill>
                 <a:latin typeface="Yu Gothic"/>
               </a:rPr>
-              <a:t>次回お会いした時に「やってみてどうだったか」を一緒に振り返ります</a:t>
+              <a:t>次回ヒアリングで運用状況を確認</a:t>
             </a:r>
           </a:p>
         </p:txBody>
@@ -6756,7 +6740,7 @@
         </p:nvSpPr>
         <p:spPr>
           <a:xfrm>
-            <a:off x="0" y="2286000"/>
+            <a:off x="0" y="2743200"/>
             <a:ext cx="9144000" cy="914400"/>
           </a:xfrm>
           <a:prstGeom prst="rect">
@@ -6782,7 +6766,7 @@
                 </a:solidFill>
                 <a:latin typeface="Yu Mincho"/>
               </a:rPr>
-              <a:t>うたかたが続くように</a:t>
+              <a:t>以上</a:t>
             </a:r>
           </a:p>
         </p:txBody>
@@ -6795,7 +6779,7 @@
         </p:nvSpPr>
         <p:spPr>
           <a:xfrm>
-            <a:off x="4297680" y="3657600"/>
+            <a:off x="4297680" y="3840480"/>
             <a:ext cx="548640" cy="9525"/>
           </a:xfrm>
           <a:prstGeom prst="rect">
@@ -6838,8 +6822,8 @@
         </p:nvSpPr>
         <p:spPr>
           <a:xfrm>
-            <a:off x="0" y="4114800"/>
-            <a:ext cx="9144000" cy="1828800"/>
+            <a:off x="0" y="4297680"/>
+            <a:ext cx="9144000" cy="548640"/>
           </a:xfrm>
           <a:prstGeom prst="rect">
             <a:avLst/>
@@ -6854,7 +6838,7 @@
           <a:p>
             <a:pPr algn="ctr">
               <a:lnSpc>
-                <a:spcPct val="200000"/>
+                <a:spcPct val="140000"/>
               </a:lnSpc>
             </a:pPr>
             <a:r>
@@ -6864,39 +6848,7 @@
                 </a:solidFill>
                 <a:latin typeface="Yu Gothic"/>
               </a:rPr>
-              <a:t>「整える時間」を、整えながら届けられるように。</a:t>
-            </a:r>
-          </a:p>
-          <a:p>
-            <a:pPr algn="ctr">
-              <a:lnSpc>
-                <a:spcPct val="200000"/>
-              </a:lnSpc>
-            </a:pPr>
-            <a:r>
-              <a:rPr sz="1200" b="0" i="0">
-                <a:solidFill>
-                  <a:srgbClr val="CFCBC0"/>
-                </a:solidFill>
-                <a:latin typeface="Yu Gothic"/>
-              </a:rPr>
-              <a:t>無理せず、長く続けられる仕組みを</a:t>
-            </a:r>
-          </a:p>
-          <a:p>
-            <a:pPr algn="ctr">
-              <a:lnSpc>
-                <a:spcPct val="200000"/>
-              </a:lnSpc>
-            </a:pPr>
-            <a:r>
-              <a:rPr sz="1200" b="0" i="0">
-                <a:solidFill>
-                  <a:srgbClr val="CFCBC0"/>
-                </a:solidFill>
-                <a:latin typeface="Yu Gothic"/>
-              </a:rPr>
-              <a:t>これからも一緒に組み立てさせてください。</a:t>
+              <a:t>ご質問・ご意見をお願いします</a:t>
             </a:r>
           </a:p>
         </p:txBody>
@@ -7109,7 +7061,7 @@
                 </a:solidFill>
                 <a:latin typeface="Yu Mincho"/>
               </a:rPr>
-              <a:t>本日お話しすること</a:t>
+              <a:t>アジェンダ</a:t>
             </a:r>
           </a:p>
         </p:txBody>
@@ -7148,7 +7100,7 @@
                 </a:solidFill>
                 <a:latin typeface="Yu Gothic"/>
               </a:rPr>
-              <a:t>前回お聞きしたお悩みをもとに、整理したものをご報告します</a:t>
+              <a:t>前回ヒアリングの振り返りと、今回の提案2点</a:t>
             </a:r>
           </a:p>
         </p:txBody>
@@ -7226,7 +7178,7 @@
                 </a:solidFill>
                 <a:latin typeface="Yu Mincho"/>
               </a:rPr>
-              <a:t>前回のヒアリング振り返り</a:t>
+              <a:t>前回ヒアリングの振り返り</a:t>
             </a:r>
           </a:p>
         </p:txBody>
@@ -7265,7 +7217,7 @@
                 </a:solidFill>
                 <a:latin typeface="Yu Gothic"/>
               </a:rPr>
-              <a:t>どんなお悩みが出てきたか、その整理</a:t>
+              <a:t>前回出た課題の整理</a:t>
             </a:r>
           </a:p>
         </p:txBody>
@@ -7378,7 +7330,7 @@
                 </a:solidFill>
                 <a:latin typeface="Yu Mincho"/>
               </a:rPr>
-              <a:t>【提案①】プロンプト一覧のご紹介</a:t>
+              <a:t>提案① プロンプト一覧</a:t>
             </a:r>
           </a:p>
         </p:txBody>
@@ -7417,7 +7369,7 @@
                 </a:solidFill>
                 <a:latin typeface="Yu Gothic"/>
               </a:rPr>
-              <a:t>ChatGPTで投稿の言葉づくりを楽にする道具</a:t>
+              <a:t>投稿の言葉づくり用ツール</a:t>
             </a:r>
           </a:p>
         </p:txBody>
@@ -7530,7 +7482,7 @@
                 </a:solidFill>
                 <a:latin typeface="Yu Mincho"/>
               </a:rPr>
-              <a:t>【提案②】動画エディタの使い方レクチャー</a:t>
+              <a:t>提案② 動画エディタ</a:t>
             </a:r>
           </a:p>
         </p:txBody>
@@ -7569,7 +7521,7 @@
                 </a:solidFill>
                 <a:latin typeface="Yu Gothic"/>
               </a:rPr>
-              <a:t>テロップ位置を悩まずに済む、ブラウザツール</a:t>
+              <a:t>テロップ位置調整不要の編集ツール</a:t>
             </a:r>
           </a:p>
         </p:txBody>
@@ -7721,7 +7673,7 @@
                 </a:solidFill>
                 <a:latin typeface="Yu Gothic"/>
               </a:rPr>
-              <a:t>3週間で無理なく取り入れる順番</a:t>
+              <a:t>3週間の導入計画</a:t>
             </a:r>
           </a:p>
         </p:txBody>
@@ -7830,7 +7782,7 @@
                 </a:solidFill>
                 <a:latin typeface="Yu Gothic"/>
               </a:rPr>
-              <a:t>30分のお時間で、ゆっくりお話しできればと思います</a:t>
+              <a:t>所要 約30分</a:t>
             </a:r>
           </a:p>
         </p:txBody>
@@ -8043,7 +7995,7 @@
                 </a:solidFill>
                 <a:latin typeface="Yu Mincho"/>
               </a:rPr>
-              <a:t>前回のヒアリングで見えてきたこと</a:t>
+              <a:t>前回ヒアリングで出た課題</a:t>
             </a:r>
           </a:p>
         </p:txBody>
@@ -8082,7 +8034,7 @@
                 </a:solidFill>
                 <a:latin typeface="Yu Gothic"/>
               </a:rPr>
-              <a:t>うたかた様から伺ったお悩み・違和感を、4つに整理しました</a:t>
+              <a:t>ヒアリング内容を4点に整理</a:t>
             </a:r>
           </a:p>
         </p:txBody>
@@ -8884,7 +8836,7 @@
                 </a:solidFill>
                 <a:latin typeface="Yu Gothic"/>
               </a:rPr>
-              <a:t>※ 前回のメモから抜粋。漏れがあれば後ほど追記します</a:t>
+              <a:t>※ ヒアリングメモから抜粋</a:t>
             </a:r>
           </a:p>
         </p:txBody>
@@ -9097,7 +9049,7 @@
                 </a:solidFill>
                 <a:latin typeface="Yu Mincho"/>
               </a:rPr>
-              <a:t>大事にしていらっしゃること</a:t>
+              <a:t>ブランドの軸</a:t>
             </a:r>
           </a:p>
         </p:txBody>
@@ -9136,7 +9088,7 @@
                 </a:solidFill>
                 <a:latin typeface="Yu Gothic"/>
               </a:rPr>
-              <a:t>これを軸に、すべての提案を組み立てています</a:t>
+              <a:t>提案の判断基準</a:t>
             </a:r>
           </a:p>
         </p:txBody>
@@ -9792,7 +9744,7 @@
                 </a:solidFill>
                 <a:latin typeface="Yu Gothic"/>
               </a:rPr>
-              <a:t>この3つの軸から外れたものはご提案しません</a:t>
+              <a:t>提案はこの軸に沿って組み立て</a:t>
             </a:r>
           </a:p>
         </p:txBody>
@@ -10005,7 +9957,7 @@
                 </a:solidFill>
                 <a:latin typeface="Yu Mincho"/>
               </a:rPr>
-              <a:t>3つのアプローチで楽にしていきます</a:t>
+              <a:t>3つのアプローチ</a:t>
             </a:r>
           </a:p>
         </p:txBody>
@@ -10044,7 +9996,7 @@
                 </a:solidFill>
                 <a:latin typeface="Yu Gothic"/>
               </a:rPr>
-              <a:t>「すべてAI任せ」ではなく、人の判断は残しつつ手間だけ減らす</a:t>
+              <a:t>AI任せにせず、人の判断を残す設計</a:t>
             </a:r>
           </a:p>
         </p:txBody>
@@ -10626,7 +10578,7 @@
                 </a:solidFill>
                 <a:latin typeface="Yu Mincho"/>
               </a:rPr>
-              <a:t>本日は ① と ② をご紹介します。</a:t>
+              <a:t>本日は ① と ② を扱う。</a:t>
             </a:r>
           </a:p>
           <a:p>
@@ -10642,7 +10594,7 @@
                 </a:solidFill>
                 <a:latin typeface="Yu Mincho"/>
               </a:rPr>
-              <a:t>③（撮影設計）は別途お渡ししたガイドをご覧ください。</a:t>
+              <a:t>③（撮影設計）は別資料を参照。</a:t>
             </a:r>
           </a:p>
         </p:txBody>
@@ -11050,7 +11002,7 @@
                 </a:solidFill>
                 <a:latin typeface="Yu Gothic"/>
               </a:rPr>
-              <a:t>「何を投稿しよう？」を5秒で解決する道具箱</a:t>
+              <a:t>ChatGPTで投稿の言葉づくりを高速化</a:t>
             </a:r>
           </a:p>
         </p:txBody>
@@ -11089,7 +11041,7 @@
                 </a:solidFill>
                 <a:latin typeface="Yu Mincho"/>
               </a:rPr>
-              <a:t>ChatGPTに「リール5本」と打つだけで、</a:t>
+              <a:t>ChatGPTに「リール5本」のような短いトリガー語を打つと、</a:t>
             </a:r>
           </a:p>
           <a:p>
@@ -11105,7 +11057,7 @@
                 </a:solidFill>
                 <a:latin typeface="Yu Mincho"/>
               </a:rPr>
-              <a:t>うたかたらしい台本が5本まとめて生成される、というイメージです。</a:t>
+              <a:t>ブランドに沿った投稿案がまとめて出力される仕組み。</a:t>
             </a:r>
           </a:p>
           <a:p>
@@ -11137,7 +11089,7 @@
                 </a:solidFill>
                 <a:latin typeface="Yu Mincho"/>
               </a:rPr>
-              <a:t>毎回ゼロから考える必要がなくなります。</a:t>
+              <a:t>投稿のたびにゼロから考える時間を削減。</a:t>
             </a:r>
           </a:p>
         </p:txBody>
@@ -11463,7 +11415,7 @@
                 </a:solidFill>
                 <a:latin typeface="Yu Gothic"/>
               </a:rPr>
-              <a:t>用途別に短い言葉を1つ打つだけで、必要な発信素材が出てきます</a:t>
+              <a:t>用途別のトリガー語を15種類用意</a:t>
             </a:r>
           </a:p>
         </p:txBody>
@@ -13382,7 +13334,7 @@
                 </a:solidFill>
                 <a:latin typeface="Yu Gothic"/>
               </a:rPr>
-              <a:t>たとえば「今月どうしよう」→「月次テーマ」と打つだけ</a:t>
+              <a:t>例: 月の方針が定まらない時は「月次テーマ」</a:t>
             </a:r>
           </a:p>
         </p:txBody>
@@ -13634,7 +13586,7 @@
                 </a:solidFill>
                 <a:latin typeface="Yu Gothic"/>
               </a:rPr>
-              <a:t>難しい操作は不要。事前準備は1回だけ。</a:t>
+              <a:t>事前準備は1回のみ</a:t>
             </a:r>
           </a:p>
         </p:txBody>
@@ -14478,7 +14430,7 @@
                 </a:solidFill>
                 <a:latin typeface="Yu Gothic"/>
               </a:rPr>
-              <a:t>投稿1本あたり 3〜5分 で言葉が決まります</a:t>
+              <a:t>1投稿あたり 3〜5分 で完成</a:t>
             </a:r>
           </a:p>
         </p:txBody>
@@ -14552,7 +14504,7 @@
                 </a:solidFill>
                 <a:latin typeface="Yu Gothic"/>
               </a:rPr>
-              <a:t>本日その場で1回試してみましょう</a:t>
+              <a:t>本日デモを実施</a:t>
             </a:r>
           </a:p>
         </p:txBody>
@@ -14886,7 +14838,7 @@
                 </a:solidFill>
                 <a:latin typeface="Yu Gothic"/>
               </a:rPr>
-              <a:t>テロップ位置を悩まずに済む、ブラウザで動く編集ツール</a:t>
+              <a:t>テロップ位置を悩まないブラウザ完結ツール</a:t>
             </a:r>
           </a:p>
         </p:txBody>
@@ -14941,7 +14893,7 @@
                 </a:solidFill>
                 <a:latin typeface="Yu Mincho"/>
               </a:rPr>
-              <a:t>動画の上下に固定された枠に文字を入れる仕組みです。</a:t>
+              <a:t>動画の上下に固定の枠を設けて文字を入れる仕組み。</a:t>
             </a:r>
           </a:p>
           <a:p>
@@ -14973,7 +14925,7 @@
                 </a:solidFill>
                 <a:latin typeface="Yu Mincho"/>
               </a:rPr>
-              <a:t>→ テロップが顔に被る心配がない</a:t>
+              <a:t>・テロップが顔に被らない</a:t>
             </a:r>
           </a:p>
           <a:p>
@@ -14989,7 +14941,7 @@
                 </a:solidFill>
                 <a:latin typeface="Yu Mincho"/>
               </a:rPr>
-              <a:t>→ 位置調整がいらない</a:t>
+              <a:t>・位置調整が不要</a:t>
             </a:r>
           </a:p>
           <a:p>
@@ -15005,7 +14957,7 @@
                 </a:solidFill>
                 <a:latin typeface="Yu Mincho"/>
               </a:rPr>
-              <a:t>→ うたかたらしい統一感を保ったまま量産できる</a:t>
+              <a:t>・ブランドの統一感を保ったまま量産可能</a:t>
             </a:r>
           </a:p>
         </p:txBody>

</xml_diff>

<commit_message>
Harden language: replace poetic axes with business-formal criteria
- スライド4(軸)の「静/間/続」を 01/02/03 と業務基準表記に置換
  - 押し売りしない / 過剰演出しない / 継続可能なペース
- 「呼吸が落ち着く」「そっと置いておく」等の詩的表現を削除
- ロードマップの語尾を業務報告調に統一(試す→実行、作る→作成 等)
- WEEK 03タイトルを「慣れる・調整」→「運用に乗せる」
</commit_message>
<xml_diff>
--- a/salon-slides.pptx
+++ b/salon-slides.pptx
@@ -6327,7 +6327,7 @@
                 </a:solidFill>
                 <a:latin typeface="Yu Mincho"/>
               </a:rPr>
-              <a:t>エディタで1本作る</a:t>
+              <a:t>エディタで1本作成</a:t>
             </a:r>
           </a:p>
         </p:txBody>
@@ -9172,7 +9172,7 @@
                 </a:solidFill>
                 <a:latin typeface="Yu Mincho"/>
               </a:rPr>
-              <a:t>静</a:t>
+              <a:t>01</a:t>
             </a:r>
           </a:p>
         </p:txBody>
@@ -9211,7 +9211,7 @@
                 </a:solidFill>
                 <a:latin typeface="Yu Mincho"/>
               </a:rPr>
-              <a:t>静かに整える</a:t>
+              <a:t>押し売りしない</a:t>
             </a:r>
           </a:p>
         </p:txBody>
@@ -9250,7 +9250,7 @@
                 </a:solidFill>
                 <a:latin typeface="Yu Gothic"/>
               </a:rPr>
-              <a:t>派手な表現ではなく、</a:t>
+              <a:t>感情を煽る表現・</a:t>
             </a:r>
           </a:p>
           <a:p>
@@ -9266,23 +9266,7 @@
                 </a:solidFill>
                 <a:latin typeface="Yu Gothic"/>
               </a:rPr>
-              <a:t>呼吸が落ち着くような</a:t>
-            </a:r>
-          </a:p>
-          <a:p>
-            <a:pPr algn="ctr">
-              <a:lnSpc>
-                <a:spcPct val="160000"/>
-              </a:lnSpc>
-            </a:pPr>
-            <a:r>
-              <a:rPr sz="1000" b="0" i="0">
-                <a:solidFill>
-                  <a:srgbClr val="7A7A7A"/>
-                </a:solidFill>
-                <a:latin typeface="Yu Gothic"/>
-              </a:rPr>
-              <a:t>言葉と画</a:t>
+              <a:t>割引強調は使わない</a:t>
             </a:r>
           </a:p>
         </p:txBody>
@@ -9366,7 +9350,7 @@
                 </a:solidFill>
                 <a:latin typeface="Yu Mincho"/>
               </a:rPr>
-              <a:t>間</a:t>
+              <a:t>02</a:t>
             </a:r>
           </a:p>
         </p:txBody>
@@ -9405,7 +9389,7 @@
                 </a:solidFill>
                 <a:latin typeface="Yu Mincho"/>
               </a:rPr>
-              <a:t>押し売りしない</a:t>
+              <a:t>過剰演出しない</a:t>
             </a:r>
           </a:p>
         </p:txBody>
@@ -9444,7 +9428,7 @@
                 </a:solidFill>
                 <a:latin typeface="Yu Gothic"/>
               </a:rPr>
-              <a:t>来てください、より</a:t>
+              <a:t>「劇的」「絶対」など</a:t>
             </a:r>
           </a:p>
           <a:p>
@@ -9460,23 +9444,7 @@
                 </a:solidFill>
                 <a:latin typeface="Yu Gothic"/>
               </a:rPr>
-              <a:t>「そういう時間がある」と</a:t>
-            </a:r>
-          </a:p>
-          <a:p>
-            <a:pPr algn="ctr">
-              <a:lnSpc>
-                <a:spcPct val="160000"/>
-              </a:lnSpc>
-            </a:pPr>
-            <a:r>
-              <a:rPr sz="1000" b="0" i="0">
-                <a:solidFill>
-                  <a:srgbClr val="7A7A7A"/>
-                </a:solidFill>
-                <a:latin typeface="Yu Gothic"/>
-              </a:rPr>
-              <a:t>そっと置いておく</a:t>
+              <a:t>誇張表現は不可</a:t>
             </a:r>
           </a:p>
         </p:txBody>
@@ -9560,7 +9528,7 @@
                 </a:solidFill>
                 <a:latin typeface="Yu Mincho"/>
               </a:rPr>
-              <a:t>続</a:t>
+              <a:t>03</a:t>
             </a:r>
           </a:p>
         </p:txBody>
@@ -9599,7 +9567,7 @@
                 </a:solidFill>
                 <a:latin typeface="Yu Mincho"/>
               </a:rPr>
-              <a:t>無理なく続ける</a:t>
+              <a:t>継続可能なペース</a:t>
             </a:r>
           </a:p>
         </p:txBody>
@@ -9638,7 +9606,7 @@
                 </a:solidFill>
                 <a:latin typeface="Yu Gothic"/>
               </a:rPr>
-              <a:t>毎日張り切る必要はない</a:t>
+              <a:t>月3〜4本ペースで</a:t>
             </a:r>
           </a:p>
           <a:p>
@@ -9654,23 +9622,7 @@
                 </a:solidFill>
                 <a:latin typeface="Yu Gothic"/>
               </a:rPr>
-              <a:t>月3〜4本のリズムで</a:t>
-            </a:r>
-          </a:p>
-          <a:p>
-            <a:pPr algn="ctr">
-              <a:lnSpc>
-                <a:spcPct val="160000"/>
-              </a:lnSpc>
-            </a:pPr>
-            <a:r>
-              <a:rPr sz="1000" b="0" i="0">
-                <a:solidFill>
-                  <a:srgbClr val="7A7A7A"/>
-                </a:solidFill>
-                <a:latin typeface="Yu Gothic"/>
-              </a:rPr>
-              <a:t>長く続ける</a:t>
+              <a:t>運用負荷を制御</a:t>
             </a:r>
           </a:p>
         </p:txBody>
@@ -9744,7 +9696,7 @@
                 </a:solidFill>
                 <a:latin typeface="Yu Gothic"/>
               </a:rPr>
-              <a:t>提案はこの軸に沿って組み立て</a:t>
+              <a:t>提案はこの3基準を満たすこと</a:t>
             </a:r>
           </a:p>
         </p:txBody>

</xml_diff>

<commit_message>
Sync hardened slides to main
</commit_message>
<xml_diff>
--- a/salon-slides.pptx
+++ b/salon-slides.pptx
@@ -6327,7 +6327,7 @@
                 </a:solidFill>
                 <a:latin typeface="Yu Mincho"/>
               </a:rPr>
-              <a:t>エディタで1本作る</a:t>
+              <a:t>エディタで1本作成</a:t>
             </a:r>
           </a:p>
         </p:txBody>
@@ -9172,7 +9172,7 @@
                 </a:solidFill>
                 <a:latin typeface="Yu Mincho"/>
               </a:rPr>
-              <a:t>静</a:t>
+              <a:t>01</a:t>
             </a:r>
           </a:p>
         </p:txBody>
@@ -9211,7 +9211,7 @@
                 </a:solidFill>
                 <a:latin typeface="Yu Mincho"/>
               </a:rPr>
-              <a:t>静かに整える</a:t>
+              <a:t>押し売りしない</a:t>
             </a:r>
           </a:p>
         </p:txBody>
@@ -9250,7 +9250,7 @@
                 </a:solidFill>
                 <a:latin typeface="Yu Gothic"/>
               </a:rPr>
-              <a:t>派手な表現ではなく、</a:t>
+              <a:t>感情を煽る表現・</a:t>
             </a:r>
           </a:p>
           <a:p>
@@ -9266,23 +9266,7 @@
                 </a:solidFill>
                 <a:latin typeface="Yu Gothic"/>
               </a:rPr>
-              <a:t>呼吸が落ち着くような</a:t>
-            </a:r>
-          </a:p>
-          <a:p>
-            <a:pPr algn="ctr">
-              <a:lnSpc>
-                <a:spcPct val="160000"/>
-              </a:lnSpc>
-            </a:pPr>
-            <a:r>
-              <a:rPr sz="1000" b="0" i="0">
-                <a:solidFill>
-                  <a:srgbClr val="7A7A7A"/>
-                </a:solidFill>
-                <a:latin typeface="Yu Gothic"/>
-              </a:rPr>
-              <a:t>言葉と画</a:t>
+              <a:t>割引強調は使わない</a:t>
             </a:r>
           </a:p>
         </p:txBody>
@@ -9366,7 +9350,7 @@
                 </a:solidFill>
                 <a:latin typeface="Yu Mincho"/>
               </a:rPr>
-              <a:t>間</a:t>
+              <a:t>02</a:t>
             </a:r>
           </a:p>
         </p:txBody>
@@ -9405,7 +9389,7 @@
                 </a:solidFill>
                 <a:latin typeface="Yu Mincho"/>
               </a:rPr>
-              <a:t>押し売りしない</a:t>
+              <a:t>過剰演出しない</a:t>
             </a:r>
           </a:p>
         </p:txBody>
@@ -9444,7 +9428,7 @@
                 </a:solidFill>
                 <a:latin typeface="Yu Gothic"/>
               </a:rPr>
-              <a:t>来てください、より</a:t>
+              <a:t>「劇的」「絶対」など</a:t>
             </a:r>
           </a:p>
           <a:p>
@@ -9460,23 +9444,7 @@
                 </a:solidFill>
                 <a:latin typeface="Yu Gothic"/>
               </a:rPr>
-              <a:t>「そういう時間がある」と</a:t>
-            </a:r>
-          </a:p>
-          <a:p>
-            <a:pPr algn="ctr">
-              <a:lnSpc>
-                <a:spcPct val="160000"/>
-              </a:lnSpc>
-            </a:pPr>
-            <a:r>
-              <a:rPr sz="1000" b="0" i="0">
-                <a:solidFill>
-                  <a:srgbClr val="7A7A7A"/>
-                </a:solidFill>
-                <a:latin typeface="Yu Gothic"/>
-              </a:rPr>
-              <a:t>そっと置いておく</a:t>
+              <a:t>誇張表現は不可</a:t>
             </a:r>
           </a:p>
         </p:txBody>
@@ -9560,7 +9528,7 @@
                 </a:solidFill>
                 <a:latin typeface="Yu Mincho"/>
               </a:rPr>
-              <a:t>続</a:t>
+              <a:t>03</a:t>
             </a:r>
           </a:p>
         </p:txBody>
@@ -9599,7 +9567,7 @@
                 </a:solidFill>
                 <a:latin typeface="Yu Mincho"/>
               </a:rPr>
-              <a:t>無理なく続ける</a:t>
+              <a:t>継続可能なペース</a:t>
             </a:r>
           </a:p>
         </p:txBody>
@@ -9638,7 +9606,7 @@
                 </a:solidFill>
                 <a:latin typeface="Yu Gothic"/>
               </a:rPr>
-              <a:t>毎日張り切る必要はない</a:t>
+              <a:t>月3〜4本ペースで</a:t>
             </a:r>
           </a:p>
           <a:p>
@@ -9654,23 +9622,7 @@
                 </a:solidFill>
                 <a:latin typeface="Yu Gothic"/>
               </a:rPr>
-              <a:t>月3〜4本のリズムで</a:t>
-            </a:r>
-          </a:p>
-          <a:p>
-            <a:pPr algn="ctr">
-              <a:lnSpc>
-                <a:spcPct val="160000"/>
-              </a:lnSpc>
-            </a:pPr>
-            <a:r>
-              <a:rPr sz="1000" b="0" i="0">
-                <a:solidFill>
-                  <a:srgbClr val="7A7A7A"/>
-                </a:solidFill>
-                <a:latin typeface="Yu Gothic"/>
-              </a:rPr>
-              <a:t>長く続ける</a:t>
+              <a:t>運用負荷を制御</a:t>
             </a:r>
           </a:p>
         </p:txBody>
@@ -9744,7 +9696,7 @@
                 </a:solidFill>
                 <a:latin typeface="Yu Gothic"/>
               </a:rPr>
-              <a:t>提案はこの軸に沿って組み立て</a:t>
+              <a:t>提案はこの3基準を満たすこと</a:t>
             </a:r>
           </a:p>
         </p:txBody>

</xml_diff>